<commit_message>
move Summ Stats section in main slides
</commit_message>
<xml_diff>
--- a/docs/DSR-II2026_JL_slides.pptx
+++ b/docs/DSR-II2026_JL_slides.pptx
@@ -3249,7 +3249,7 @@
           <a:p>
             <a:fld id="{C764DE79-268F-4C1A-8933-263129D2AF90}" type="datetimeFigureOut">
               <a:rPr lang="en-US" dirty="0"/>
-              <a:t>3/17/2026</a:t>
+              <a:t>3/18/2026</a:t>
             </a:fld>
             <a:endParaRPr lang="en-US" dirty="0"/>
           </a:p>
@@ -3526,7 +3526,7 @@
           <a:p>
             <a:fld id="{C764DE79-268F-4C1A-8933-263129D2AF90}" type="datetimeFigureOut">
               <a:rPr lang="en-US" dirty="0"/>
-              <a:t>3/17/2026</a:t>
+              <a:t>3/18/2026</a:t>
             </a:fld>
             <a:endParaRPr lang="en-US" dirty="0"/>
           </a:p>
@@ -3783,7 +3783,7 @@
           <a:p>
             <a:fld id="{C764DE79-268F-4C1A-8933-263129D2AF90}" type="datetimeFigureOut">
               <a:rPr lang="en-US" dirty="0"/>
-              <a:t>3/17/2026</a:t>
+              <a:t>3/18/2026</a:t>
             </a:fld>
             <a:endParaRPr lang="en-US" dirty="0"/>
           </a:p>
@@ -3953,7 +3953,7 @@
           <a:p>
             <a:fld id="{C764DE79-268F-4C1A-8933-263129D2AF90}" type="datetimeFigureOut">
               <a:rPr lang="en-US" dirty="0"/>
-              <a:t>3/17/2026</a:t>
+              <a:t>3/18/2026</a:t>
             </a:fld>
             <a:endParaRPr lang="en-US" dirty="0"/>
           </a:p>
@@ -4133,7 +4133,7 @@
           <a:p>
             <a:fld id="{C764DE79-268F-4C1A-8933-263129D2AF90}" type="datetimeFigureOut">
               <a:rPr lang="en-US" dirty="0"/>
-              <a:t>3/17/2026</a:t>
+              <a:t>3/18/2026</a:t>
             </a:fld>
             <a:endParaRPr lang="en-US" dirty="0"/>
           </a:p>
@@ -4589,7 +4589,7 @@
           <a:p>
             <a:fld id="{C764DE79-268F-4C1A-8933-263129D2AF90}" type="datetimeFigureOut">
               <a:rPr lang="en-US" dirty="0"/>
-              <a:t>3/17/2026</a:t>
+              <a:t>3/18/2026</a:t>
             </a:fld>
             <a:endParaRPr lang="en-US" dirty="0"/>
           </a:p>
@@ -4759,7 +4759,7 @@
           <a:p>
             <a:fld id="{C764DE79-268F-4C1A-8933-263129D2AF90}" type="datetimeFigureOut">
               <a:rPr lang="en-US" dirty="0"/>
-              <a:t>3/17/2026</a:t>
+              <a:t>3/18/2026</a:t>
             </a:fld>
             <a:endParaRPr lang="en-US" dirty="0"/>
           </a:p>
@@ -5005,7 +5005,7 @@
           <a:p>
             <a:fld id="{C764DE79-268F-4C1A-8933-263129D2AF90}" type="datetimeFigureOut">
               <a:rPr lang="en-US" dirty="0"/>
-              <a:t>3/17/2026</a:t>
+              <a:t>3/18/2026</a:t>
             </a:fld>
             <a:endParaRPr lang="en-US" dirty="0"/>
           </a:p>
@@ -5237,7 +5237,7 @@
           <a:p>
             <a:fld id="{C764DE79-268F-4C1A-8933-263129D2AF90}" type="datetimeFigureOut">
               <a:rPr lang="en-US" dirty="0"/>
-              <a:t>3/17/2026</a:t>
+              <a:t>3/18/2026</a:t>
             </a:fld>
             <a:endParaRPr lang="en-US" dirty="0"/>
           </a:p>
@@ -5604,7 +5604,7 @@
           <a:p>
             <a:fld id="{C764DE79-268F-4C1A-8933-263129D2AF90}" type="datetimeFigureOut">
               <a:rPr lang="en-US" dirty="0"/>
-              <a:t>3/17/2026</a:t>
+              <a:t>3/18/2026</a:t>
             </a:fld>
             <a:endParaRPr lang="en-US" dirty="0"/>
           </a:p>
@@ -5722,7 +5722,7 @@
           <a:p>
             <a:fld id="{C764DE79-268F-4C1A-8933-263129D2AF90}" type="datetimeFigureOut">
               <a:rPr lang="en-US" dirty="0"/>
-              <a:t>3/17/2026</a:t>
+              <a:t>3/18/2026</a:t>
             </a:fld>
             <a:endParaRPr lang="en-US" dirty="0"/>
           </a:p>
@@ -7065,7 +7065,7 @@
           <a:p>
             <a:fld id="{C764DE79-268F-4C1A-8933-263129D2AF90}" type="datetimeFigureOut">
               <a:rPr lang="en-US" dirty="0"/>
-              <a:t>3/17/2026</a:t>
+              <a:t>3/18/2026</a:t>
             </a:fld>
             <a:endParaRPr lang="en-US" dirty="0"/>
           </a:p>
@@ -8770,7 +8770,7 @@
         <p:spPr bwMode="auto">
           <a:xfrm>
             <a:off x="2711625" y="1557339"/>
-            <a:ext cx="4968875" cy="3752309"/>
+            <a:ext cx="4968875" cy="4062651"/>
           </a:xfrm>
           <a:prstGeom prst="rect">
             <a:avLst/>
@@ -8815,7 +8815,28 @@
                 </a:solidFill>
                 <a:latin typeface="Humnst777 BT" pitchFamily="34" charset="0"/>
               </a:rPr>
-              <a:t>Variação</a:t>
+              <a:t>Estatísticas descritivas</a:t>
+            </a:r>
+          </a:p>
+          <a:p>
+            <a:pPr>
+              <a:spcBef>
+                <a:spcPts val="500"/>
+              </a:spcBef>
+              <a:buClr>
+                <a:srgbClr val="CC0000"/>
+              </a:buClr>
+              <a:buFont typeface="Wingdings" pitchFamily="2" charset="2"/>
+              <a:buChar char="§"/>
+            </a:pPr>
+            <a:r>
+              <a:rPr lang="pt-PT" sz="1600" b="1" dirty="0">
+                <a:solidFill>
+                  <a:srgbClr val="003E6C"/>
+                </a:solidFill>
+                <a:latin typeface="Humnst777 BT" pitchFamily="34" charset="0"/>
+              </a:rPr>
+              <a:t> Variação</a:t>
             </a:r>
           </a:p>
           <a:p>
@@ -9173,7 +9194,7 @@
         <p:spPr bwMode="auto">
           <a:xfrm>
             <a:off x="2712914" y="1557338"/>
-            <a:ext cx="372" cy="3780000"/>
+            <a:ext cx="372" cy="3960000"/>
           </a:xfrm>
           <a:prstGeom prst="line">
             <a:avLst/>
@@ -9213,7 +9234,7 @@
         <p:spPr bwMode="auto">
           <a:xfrm>
             <a:off x="7248128" y="1557339"/>
-            <a:ext cx="2606414" cy="3765133"/>
+            <a:ext cx="2606414" cy="4075475"/>
           </a:xfrm>
           <a:prstGeom prst="rect">
             <a:avLst/>
@@ -9291,6 +9312,22 @@
                 <a:srgbClr val="CC0000"/>
               </a:buClr>
             </a:pPr>
+            <a:endParaRPr lang="pt-PT" sz="1600" dirty="0">
+              <a:solidFill>
+                <a:srgbClr val="003E6C"/>
+              </a:solidFill>
+              <a:latin typeface="Humnst777 BT" pitchFamily="34" charset="0"/>
+            </a:endParaRPr>
+          </a:p>
+          <a:p>
+            <a:pPr algn="r">
+              <a:spcBef>
+                <a:spcPts val="500"/>
+              </a:spcBef>
+              <a:buClr>
+                <a:srgbClr val="CC0000"/>
+              </a:buClr>
+            </a:pPr>
             <a:r>
               <a:rPr lang="pt-PT" sz="1600" dirty="0">
                 <a:solidFill>
@@ -9365,7 +9402,26 @@
                 </a:solidFill>
                 <a:latin typeface="Humnst777 BT" pitchFamily="34" charset="0"/>
               </a:rPr>
-              <a:t>14:00 - 16:00</a:t>
+              <a:t>14:00 - 15:00</a:t>
+            </a:r>
+          </a:p>
+          <a:p>
+            <a:pPr algn="r">
+              <a:spcBef>
+                <a:spcPts val="500"/>
+              </a:spcBef>
+              <a:buClr>
+                <a:srgbClr val="CC0000"/>
+              </a:buClr>
+            </a:pPr>
+            <a:r>
+              <a:rPr lang="pt-PT" sz="1600" dirty="0">
+                <a:solidFill>
+                  <a:srgbClr val="003E6C"/>
+                </a:solidFill>
+                <a:latin typeface="Humnst777 BT" pitchFamily="34" charset="0"/>
+              </a:rPr>
+              <a:t>15:15 - 16:00</a:t>
             </a:r>
           </a:p>
           <a:p>
@@ -9403,22 +9459,6 @@
           <a:p>
             <a:pPr algn="r">
               <a:spcBef>
-                <a:spcPts val="500"/>
-              </a:spcBef>
-              <a:buClr>
-                <a:srgbClr val="CC0000"/>
-              </a:buClr>
-            </a:pPr>
-            <a:endParaRPr lang="pt-PT" sz="1600" dirty="0">
-              <a:solidFill>
-                <a:srgbClr val="003E6C"/>
-              </a:solidFill>
-              <a:latin typeface="Humnst777 BT" pitchFamily="34" charset="0"/>
-            </a:endParaRPr>
-          </a:p>
-          <a:p>
-            <a:pPr algn="r">
-              <a:spcBef>
                 <a:spcPts val="600"/>
               </a:spcBef>
               <a:buClr>
@@ -9432,7 +9472,7 @@
                 </a:solidFill>
                 <a:latin typeface="Humnst777 BT" pitchFamily="34" charset="0"/>
               </a:rPr>
-              <a:t>16:15 - 17:00</a:t>
+              <a:t>16:00 - 17:00</a:t>
             </a:r>
           </a:p>
         </p:txBody>
@@ -9493,13 +9533,15 @@
               </a:ext>
             </a:extLst>
           </p:cNvPr>
-          <p:cNvCxnSpPr/>
+          <p:cNvCxnSpPr>
+            <a:cxnSpLocks/>
+          </p:cNvCxnSpPr>
           <p:nvPr/>
         </p:nvCxnSpPr>
         <p:spPr bwMode="auto">
           <a:xfrm>
-            <a:off x="3863752" y="1720850"/>
-            <a:ext cx="4608512" cy="0"/>
+            <a:off x="4943872" y="1720850"/>
+            <a:ext cx="3528000" cy="0"/>
           </a:xfrm>
           <a:prstGeom prst="line">
             <a:avLst/>
@@ -9531,7 +9573,7 @@
         </p:nvCxnSpPr>
         <p:spPr bwMode="auto">
           <a:xfrm>
-            <a:off x="4511824" y="2636912"/>
+            <a:off x="4511824" y="2941326"/>
             <a:ext cx="3960440" cy="0"/>
           </a:xfrm>
           <a:prstGeom prst="line">
@@ -9564,7 +9606,7 @@
         </p:nvCxnSpPr>
         <p:spPr bwMode="auto">
           <a:xfrm>
-            <a:off x="4007768" y="3861048"/>
+            <a:off x="4007768" y="4165462"/>
             <a:ext cx="4464496" cy="0"/>
           </a:xfrm>
           <a:prstGeom prst="line">
@@ -9597,7 +9639,7 @@
         </p:nvCxnSpPr>
         <p:spPr bwMode="auto">
           <a:xfrm>
-            <a:off x="4727848" y="5104234"/>
+            <a:off x="4727848" y="5408648"/>
             <a:ext cx="3744416" cy="0"/>
           </a:xfrm>
           <a:prstGeom prst="line">
@@ -44681,7 +44723,7 @@
         <p:spPr bwMode="auto">
           <a:xfrm>
             <a:off x="2711625" y="1557339"/>
-            <a:ext cx="4968875" cy="4683333"/>
+            <a:ext cx="4968875" cy="4372992"/>
           </a:xfrm>
           <a:prstGeom prst="rect">
             <a:avLst/>
@@ -44790,27 +44832,6 @@
                 <a:latin typeface="Humnst777 BT" pitchFamily="34" charset="0"/>
               </a:rPr>
               <a:t> Transformações genéricas (c/ exercícios)</a:t>
-            </a:r>
-          </a:p>
-          <a:p>
-            <a:pPr lvl="1">
-              <a:spcBef>
-                <a:spcPts val="500"/>
-              </a:spcBef>
-              <a:buClr>
-                <a:srgbClr val="CC0000"/>
-              </a:buClr>
-              <a:buFont typeface="Wingdings" pitchFamily="2" charset="2"/>
-              <a:buChar char="§"/>
-            </a:pPr>
-            <a:r>
-              <a:rPr lang="pt-PT" sz="1600" dirty="0">
-                <a:solidFill>
-                  <a:srgbClr val="003E6C"/>
-                </a:solidFill>
-                <a:latin typeface="Humnst777 BT" pitchFamily="34" charset="0"/>
-              </a:rPr>
-              <a:t> Estatísticas descritivas (c/ exercícios)</a:t>
             </a:r>
           </a:p>
           <a:p>
@@ -45154,9 +45175,9 @@
           <p:nvPr/>
         </p:nvSpPr>
         <p:spPr bwMode="auto">
-          <a:xfrm>
-            <a:off x="2712914" y="1557338"/>
-            <a:ext cx="372" cy="4500000"/>
+          <a:xfrm flipH="1">
+            <a:off x="2711624" y="1557339"/>
+            <a:ext cx="1289" cy="4320000"/>
           </a:xfrm>
           <a:prstGeom prst="line">
             <a:avLst/>
@@ -45196,7 +45217,7 @@
         <p:spPr bwMode="auto">
           <a:xfrm>
             <a:off x="7248128" y="1557339"/>
-            <a:ext cx="2606414" cy="4683333"/>
+            <a:ext cx="2606414" cy="4372992"/>
           </a:xfrm>
           <a:prstGeom prst="rect">
             <a:avLst/>
@@ -45251,22 +45272,6 @@
               </a:rPr>
               <a:t>11:15 - 12:30</a:t>
             </a:r>
-          </a:p>
-          <a:p>
-            <a:pPr algn="r">
-              <a:spcBef>
-                <a:spcPts val="500"/>
-              </a:spcBef>
-              <a:buClr>
-                <a:srgbClr val="CC0000"/>
-              </a:buClr>
-            </a:pPr>
-            <a:endParaRPr lang="pt-PT" sz="1600" dirty="0">
-              <a:solidFill>
-                <a:srgbClr val="003E6C"/>
-              </a:solidFill>
-              <a:latin typeface="Humnst777 BT" pitchFamily="34" charset="0"/>
-            </a:endParaRPr>
           </a:p>
           <a:p>
             <a:pPr algn="r">
@@ -45564,7 +45569,7 @@
         </p:nvCxnSpPr>
         <p:spPr bwMode="auto">
           <a:xfrm>
-            <a:off x="3719736" y="3265934"/>
+            <a:off x="3719736" y="2953518"/>
             <a:ext cx="4752528" cy="0"/>
           </a:xfrm>
           <a:prstGeom prst="line">
@@ -45597,7 +45602,7 @@
         </p:nvCxnSpPr>
         <p:spPr bwMode="auto">
           <a:xfrm>
-            <a:off x="4439816" y="4797152"/>
+            <a:off x="4439816" y="4484736"/>
             <a:ext cx="4032448" cy="0"/>
           </a:xfrm>
           <a:prstGeom prst="line">

</xml_diff>